<commit_message>
feat: embed prototype screenshots and system architecture flowchart into PPT deck
</commit_message>
<xml_diff>
--- a/SIH26003_SmritiNER_Idea_Submission.pptx
+++ b/SIH26003_SmritiNER_Idea_Submission.pptx
@@ -14,6 +14,9 @@
     <p:sldId id="293" r:id="rId5"/>
     <p:sldId id="294" r:id="rId6"/>
     <p:sldId id="296" r:id="rId7"/>
+    <p:sldId id="297" r:id="rId8"/>
+    <p:sldId id="298" r:id="rId14"/>
+    <p:sldId id="299" r:id="rId15"/>
   </p:sldIdLst>
   <p:sldSz cx="12192000" cy="6858000"/>
   <p:notesSz cx="6858000" cy="9144000"/>
@@ -14290,6 +14293,860 @@
 </p:sld>
 </file>
 
+<file path=ppt/slides/slide7.xml><?xml version="1.0" encoding="utf-8"?>
+<p:sld xmlns:a="http://schemas.openxmlformats.org/drawingml/2006/main" xmlns:p="http://schemas.openxmlformats.org/presentationml/2006/main" xmlns:r="http://schemas.openxmlformats.org/officeDocument/2006/relationships">
+  <p:cSld>
+    <p:spTree>
+      <p:nvGrpSpPr>
+        <p:cNvPr id="1" name=""/>
+        <p:cNvGrpSpPr/>
+        <p:nvPr/>
+      </p:nvGrpSpPr>
+      <p:grpSpPr/>
+      <p:sp>
+        <p:nvSpPr>
+          <p:cNvPr id="2" name="TextBox 1"/>
+          <p:cNvSpPr txBox="1"/>
+          <p:nvPr/>
+        </p:nvSpPr>
+        <p:spPr>
+          <a:xfrm>
+            <a:off x="609904" y="-47548"/>
+            <a:ext cx="10972800" cy="1143000"/>
+          </a:xfrm>
+          <a:prstGeom prst="rect">
+            <a:avLst/>
+          </a:prstGeom>
+          <a:noFill/>
+        </p:spPr>
+        <p:txBody>
+          <a:bodyPr wrap="none">
+            <a:spAutoFit/>
+          </a:bodyPr>
+          <a:lstStyle/>
+          <a:p>
+            <a:pPr>
+              <a:defRPr sz="2800" b="1">
+                <a:solidFill>
+                  <a:srgbClr val="0F172A"/>
+                </a:solidFill>
+                <a:latin typeface="Segoe UI"/>
+              </a:defRPr>
+            </a:pPr>
+            <a:r>
+              <a:t>SYSTEM ARCHITECTURE &amp; FLOWCHART</a:t>
+            </a:r>
+          </a:p>
+        </p:txBody>
+      </p:sp>
+      <p:sp>
+        <p:nvSpPr>
+          <p:cNvPr id="3" name="Oval 2"/>
+          <p:cNvSpPr/>
+          <p:nvPr/>
+        </p:nvSpPr>
+        <p:spPr>
+          <a:xfrm>
+            <a:off x="330098" y="252374"/>
+            <a:ext cx="1251813" cy="807415"/>
+          </a:xfrm>
+          <a:prstGeom prst="ellipse">
+            <a:avLst/>
+          </a:prstGeom>
+          <a:solidFill>
+            <a:srgbClr val="10B981"/>
+          </a:solidFill>
+          <a:ln>
+            <a:solidFill>
+              <a:srgbClr val="059669"/>
+            </a:solidFill>
+          </a:ln>
+        </p:spPr>
+        <p:style>
+          <a:lnRef idx="1">
+            <a:schemeClr val="accent1"/>
+          </a:lnRef>
+          <a:fillRef idx="3">
+            <a:schemeClr val="accent1"/>
+          </a:fillRef>
+          <a:effectRef idx="2">
+            <a:schemeClr val="accent1"/>
+          </a:effectRef>
+          <a:fontRef idx="minor">
+            <a:schemeClr val="lt1"/>
+          </a:fontRef>
+        </p:style>
+        <p:txBody>
+          <a:bodyPr rtlCol="0" anchor="ctr"/>
+          <a:lstStyle/>
+          <a:p>
+            <a:pPr algn="ctr">
+              <a:defRPr sz="900" b="1">
+                <a:solidFill>
+                  <a:srgbClr val="FFFFFF"/>
+                </a:solidFill>
+              </a:defRPr>
+            </a:pPr>
+            <a:r>
+              <a:t>TEAM NAME</a:t>
+            </a:r>
+          </a:p>
+        </p:txBody>
+      </p:sp>
+      <p:sp>
+        <p:nvSpPr>
+          <p:cNvPr id="4" name="TextBox 3"/>
+          <p:cNvSpPr txBox="1"/>
+          <p:nvPr/>
+        </p:nvSpPr>
+        <p:spPr>
+          <a:xfrm>
+            <a:off x="4647895" y="6355994"/>
+            <a:ext cx="3204057" cy="364845"/>
+          </a:xfrm>
+          <a:prstGeom prst="rect">
+            <a:avLst/>
+          </a:prstGeom>
+          <a:noFill/>
+        </p:spPr>
+        <p:txBody>
+          <a:bodyPr wrap="none">
+            <a:spAutoFit/>
+          </a:bodyPr>
+          <a:lstStyle/>
+          <a:p>
+            <a:pPr>
+              <a:defRPr sz="1000">
+                <a:solidFill>
+                  <a:srgbClr val="94A3B8"/>
+                </a:solidFill>
+              </a:defRPr>
+            </a:pPr>
+            <a:r>
+              <a:t>@SIH Idea submission- Template</a:t>
+            </a:r>
+          </a:p>
+        </p:txBody>
+      </p:sp>
+      <p:sp>
+        <p:nvSpPr>
+          <p:cNvPr id="5" name="TextBox 4"/>
+          <p:cNvSpPr txBox="1"/>
+          <p:nvPr/>
+        </p:nvSpPr>
+        <p:spPr>
+          <a:xfrm>
+            <a:off x="8738006" y="6355994"/>
+            <a:ext cx="2844698" cy="364845"/>
+          </a:xfrm>
+          <a:prstGeom prst="rect">
+            <a:avLst/>
+          </a:prstGeom>
+          <a:noFill/>
+        </p:spPr>
+        <p:txBody>
+          <a:bodyPr wrap="none">
+            <a:spAutoFit/>
+          </a:bodyPr>
+          <a:lstStyle/>
+          <a:p>
+            <a:pPr>
+              <a:defRPr sz="1000" b="1">
+                <a:solidFill>
+                  <a:srgbClr val="94A3B8"/>
+                </a:solidFill>
+              </a:defRPr>
+            </a:pPr>
+            <a:r>
+              <a:t>7</a:t>
+            </a:r>
+          </a:p>
+        </p:txBody>
+      </p:sp>
+      <p:pic>
+        <p:nvPicPr>
+          <p:cNvPr id="6" name="Picture 5" descr="flowchart_diagram.png"/>
+          <p:cNvPicPr>
+            <a:picLocks noChangeAspect="1"/>
+          </p:cNvPicPr>
+          <p:nvPr/>
+        </p:nvPicPr>
+        <p:blipFill>
+          <a:blip r:embed="rId2"/>
+          <a:stretch>
+            <a:fillRect/>
+          </a:stretch>
+        </p:blipFill>
+        <p:spPr>
+          <a:xfrm>
+            <a:off x="731520" y="1188720"/>
+            <a:ext cx="10728655" cy="4937760"/>
+          </a:xfrm>
+          <a:prstGeom prst="rect">
+            <a:avLst/>
+          </a:prstGeom>
+        </p:spPr>
+      </p:pic>
+    </p:spTree>
+  </p:cSld>
+  <p:clrMapOvr>
+    <a:masterClrMapping/>
+  </p:clrMapOvr>
+</p:sld>
+</file>
+
+<file path=ppt/slides/slide8.xml><?xml version="1.0" encoding="utf-8"?>
+<p:sld xmlns:a="http://schemas.openxmlformats.org/drawingml/2006/main" xmlns:p="http://schemas.openxmlformats.org/presentationml/2006/main" xmlns:r="http://schemas.openxmlformats.org/officeDocument/2006/relationships">
+  <p:cSld>
+    <p:spTree>
+      <p:nvGrpSpPr>
+        <p:cNvPr id="1" name=""/>
+        <p:cNvGrpSpPr/>
+        <p:nvPr/>
+      </p:nvGrpSpPr>
+      <p:grpSpPr/>
+      <p:sp>
+        <p:nvSpPr>
+          <p:cNvPr id="2" name="TextBox 1"/>
+          <p:cNvSpPr txBox="1"/>
+          <p:nvPr/>
+        </p:nvSpPr>
+        <p:spPr>
+          <a:xfrm>
+            <a:off x="609904" y="-47548"/>
+            <a:ext cx="10972800" cy="1143000"/>
+          </a:xfrm>
+          <a:prstGeom prst="rect">
+            <a:avLst/>
+          </a:prstGeom>
+          <a:noFill/>
+        </p:spPr>
+        <p:txBody>
+          <a:bodyPr wrap="none">
+            <a:spAutoFit/>
+          </a:bodyPr>
+          <a:lstStyle/>
+          <a:p>
+            <a:pPr>
+              <a:defRPr sz="2800" b="1">
+                <a:solidFill>
+                  <a:srgbClr val="0F172A"/>
+                </a:solidFill>
+                <a:latin typeface="Segoe UI"/>
+              </a:defRPr>
+            </a:pPr>
+            <a:r>
+              <a:t>WORKING PROTOTYPE: ELDER HUB &amp; COGNITIVE GAMES</a:t>
+            </a:r>
+          </a:p>
+        </p:txBody>
+      </p:sp>
+      <p:sp>
+        <p:nvSpPr>
+          <p:cNvPr id="3" name="Oval 2"/>
+          <p:cNvSpPr/>
+          <p:nvPr/>
+        </p:nvSpPr>
+        <p:spPr>
+          <a:xfrm>
+            <a:off x="330098" y="252374"/>
+            <a:ext cx="1251813" cy="807415"/>
+          </a:xfrm>
+          <a:prstGeom prst="ellipse">
+            <a:avLst/>
+          </a:prstGeom>
+          <a:solidFill>
+            <a:srgbClr val="10B981"/>
+          </a:solidFill>
+          <a:ln>
+            <a:solidFill>
+              <a:srgbClr val="059669"/>
+            </a:solidFill>
+          </a:ln>
+        </p:spPr>
+        <p:style>
+          <a:lnRef idx="1">
+            <a:schemeClr val="accent1"/>
+          </a:lnRef>
+          <a:fillRef idx="3">
+            <a:schemeClr val="accent1"/>
+          </a:fillRef>
+          <a:effectRef idx="2">
+            <a:schemeClr val="accent1"/>
+          </a:effectRef>
+          <a:fontRef idx="minor">
+            <a:schemeClr val="lt1"/>
+          </a:fontRef>
+        </p:style>
+        <p:txBody>
+          <a:bodyPr rtlCol="0" anchor="ctr"/>
+          <a:lstStyle/>
+          <a:p>
+            <a:pPr algn="ctr">
+              <a:defRPr sz="900" b="1">
+                <a:solidFill>
+                  <a:srgbClr val="FFFFFF"/>
+                </a:solidFill>
+              </a:defRPr>
+            </a:pPr>
+            <a:r>
+              <a:t>TEAM NAME</a:t>
+            </a:r>
+          </a:p>
+        </p:txBody>
+      </p:sp>
+      <p:sp>
+        <p:nvSpPr>
+          <p:cNvPr id="4" name="TextBox 3"/>
+          <p:cNvSpPr txBox="1"/>
+          <p:nvPr/>
+        </p:nvSpPr>
+        <p:spPr>
+          <a:xfrm>
+            <a:off x="4647895" y="6355994"/>
+            <a:ext cx="3204057" cy="364845"/>
+          </a:xfrm>
+          <a:prstGeom prst="rect">
+            <a:avLst/>
+          </a:prstGeom>
+          <a:noFill/>
+        </p:spPr>
+        <p:txBody>
+          <a:bodyPr wrap="none">
+            <a:spAutoFit/>
+          </a:bodyPr>
+          <a:lstStyle/>
+          <a:p>
+            <a:pPr>
+              <a:defRPr sz="1000">
+                <a:solidFill>
+                  <a:srgbClr val="94A3B8"/>
+                </a:solidFill>
+              </a:defRPr>
+            </a:pPr>
+            <a:r>
+              <a:t>@SIH Idea submission- Template</a:t>
+            </a:r>
+          </a:p>
+        </p:txBody>
+      </p:sp>
+      <p:sp>
+        <p:nvSpPr>
+          <p:cNvPr id="5" name="TextBox 4"/>
+          <p:cNvSpPr txBox="1"/>
+          <p:nvPr/>
+        </p:nvSpPr>
+        <p:spPr>
+          <a:xfrm>
+            <a:off x="8738006" y="6355994"/>
+            <a:ext cx="2844698" cy="364845"/>
+          </a:xfrm>
+          <a:prstGeom prst="rect">
+            <a:avLst/>
+          </a:prstGeom>
+          <a:noFill/>
+        </p:spPr>
+        <p:txBody>
+          <a:bodyPr wrap="none">
+            <a:spAutoFit/>
+          </a:bodyPr>
+          <a:lstStyle/>
+          <a:p>
+            <a:pPr>
+              <a:defRPr sz="1000" b="1">
+                <a:solidFill>
+                  <a:srgbClr val="94A3B8"/>
+                </a:solidFill>
+              </a:defRPr>
+            </a:pPr>
+            <a:r>
+              <a:t>8</a:t>
+            </a:r>
+          </a:p>
+        </p:txBody>
+      </p:sp>
+      <p:pic>
+        <p:nvPicPr>
+          <p:cNvPr id="6" name="Picture 5" descr="screenshot_home.png"/>
+          <p:cNvPicPr>
+            <a:picLocks noChangeAspect="1"/>
+          </p:cNvPicPr>
+          <p:nvPr/>
+        </p:nvPicPr>
+        <p:blipFill>
+          <a:blip r:embed="rId2"/>
+          <a:stretch>
+            <a:fillRect/>
+          </a:stretch>
+        </p:blipFill>
+        <p:spPr>
+          <a:xfrm>
+            <a:off x="731520" y="1280160"/>
+            <a:ext cx="5212080" cy="3840480"/>
+          </a:xfrm>
+          <a:prstGeom prst="rect">
+            <a:avLst/>
+          </a:prstGeom>
+        </p:spPr>
+      </p:pic>
+      <p:sp>
+        <p:nvSpPr>
+          <p:cNvPr id="7" name="TextBox 6"/>
+          <p:cNvSpPr txBox="1"/>
+          <p:nvPr/>
+        </p:nvSpPr>
+        <p:spPr>
+          <a:xfrm>
+            <a:off x="731520" y="5212080"/>
+            <a:ext cx="5212080" cy="914400"/>
+          </a:xfrm>
+          <a:prstGeom prst="rect">
+            <a:avLst/>
+          </a:prstGeom>
+          <a:noFill/>
+        </p:spPr>
+        <p:txBody>
+          <a:bodyPr wrap="square">
+            <a:spAutoFit/>
+          </a:bodyPr>
+          <a:lstStyle/>
+          <a:p>
+            <a:pPr>
+              <a:defRPr b="1" sz="1400">
+                <a:solidFill>
+                  <a:srgbClr val="057A55"/>
+                </a:solidFill>
+              </a:defRPr>
+            </a:pPr>
+            <a:r>
+              <a:t>Prototype View 1: Senior Patient Hub</a:t>
+            </a:r>
+          </a:p>
+          <a:p>
+            <a:pPr>
+              <a:defRPr sz="1100">
+                <a:solidFill>
+                  <a:srgbClr val="475569"/>
+                </a:solidFill>
+              </a:defRPr>
+            </a:pPr>
+            <a:r>
+              <a:t>• Personalized morning greeting in Assamese/Hindi/English</a:t>
+            </a:r>
+            <a:br/>
+            <a:r>
+              <a:t>• High-Contrast WCAG AAA toggle &amp; &gt;52px tactile navigation targets</a:t>
+            </a:r>
+            <a:br/>
+            <a:r>
+              <a:t>• Audio voice guidance for non-literate rural elderly</a:t>
+            </a:r>
+          </a:p>
+        </p:txBody>
+      </p:sp>
+      <p:pic>
+        <p:nvPicPr>
+          <p:cNvPr id="8" name="Picture 7" descr="screenshot_games.png"/>
+          <p:cNvPicPr>
+            <a:picLocks noChangeAspect="1"/>
+          </p:cNvPicPr>
+          <p:nvPr/>
+        </p:nvPicPr>
+        <p:blipFill>
+          <a:blip r:embed="rId3"/>
+          <a:stretch>
+            <a:fillRect/>
+          </a:stretch>
+        </p:blipFill>
+        <p:spPr>
+          <a:xfrm>
+            <a:off x="6217920" y="1280160"/>
+            <a:ext cx="5212080" cy="3840480"/>
+          </a:xfrm>
+          <a:prstGeom prst="rect">
+            <a:avLst/>
+          </a:prstGeom>
+        </p:spPr>
+      </p:pic>
+      <p:sp>
+        <p:nvSpPr>
+          <p:cNvPr id="9" name="TextBox 8"/>
+          <p:cNvSpPr txBox="1"/>
+          <p:nvPr/>
+        </p:nvSpPr>
+        <p:spPr>
+          <a:xfrm>
+            <a:off x="6217920" y="5212080"/>
+            <a:ext cx="5212080" cy="914400"/>
+          </a:xfrm>
+          <a:prstGeom prst="rect">
+            <a:avLst/>
+          </a:prstGeom>
+          <a:noFill/>
+        </p:spPr>
+        <p:txBody>
+          <a:bodyPr wrap="square">
+            <a:spAutoFit/>
+          </a:bodyPr>
+          <a:lstStyle/>
+          <a:p>
+            <a:pPr>
+              <a:defRPr b="1" sz="1400">
+                <a:solidFill>
+                  <a:srgbClr val="057A55"/>
+                </a:solidFill>
+              </a:defRPr>
+            </a:pPr>
+            <a:r>
+              <a:t>Prototype View 2: Cognitive Gaming Arena (4 Domains)</a:t>
+            </a:r>
+          </a:p>
+          <a:p>
+            <a:pPr>
+              <a:defRPr sz="1100">
+                <a:solidFill>
+                  <a:srgbClr val="475569"/>
+                </a:solidFill>
+              </a:defRPr>
+            </a:pPr>
+            <a:r>
+              <a:t>• Cultural memory recall: Bihu Dhol, Hornbill, Muga Silk, Majuli</a:t>
+            </a:r>
+            <a:br/>
+            <a:r>
+              <a:t>• Real-time AI Adaptive pill: Latency (2.8s) &amp; Comfort Index (88%)</a:t>
+            </a:r>
+            <a:br/>
+            <a:r>
+              <a:t>• Scaffolding: Voice hints prevent frustration &amp; preserve dignity</a:t>
+            </a:r>
+          </a:p>
+        </p:txBody>
+      </p:sp>
+    </p:spTree>
+  </p:cSld>
+  <p:clrMapOvr>
+    <a:masterClrMapping/>
+  </p:clrMapOvr>
+</p:sld>
+</file>
+
+<file path=ppt/slides/slide9.xml><?xml version="1.0" encoding="utf-8"?>
+<p:sld xmlns:a="http://schemas.openxmlformats.org/drawingml/2006/main" xmlns:p="http://schemas.openxmlformats.org/presentationml/2006/main" xmlns:r="http://schemas.openxmlformats.org/officeDocument/2006/relationships">
+  <p:cSld>
+    <p:spTree>
+      <p:nvGrpSpPr>
+        <p:cNvPr id="1" name=""/>
+        <p:cNvGrpSpPr/>
+        <p:nvPr/>
+      </p:nvGrpSpPr>
+      <p:grpSpPr/>
+      <p:sp>
+        <p:nvSpPr>
+          <p:cNvPr id="2" name="TextBox 1"/>
+          <p:cNvSpPr txBox="1"/>
+          <p:nvPr/>
+        </p:nvSpPr>
+        <p:spPr>
+          <a:xfrm>
+            <a:off x="609904" y="-47548"/>
+            <a:ext cx="10972800" cy="1143000"/>
+          </a:xfrm>
+          <a:prstGeom prst="rect">
+            <a:avLst/>
+          </a:prstGeom>
+          <a:noFill/>
+        </p:spPr>
+        <p:txBody>
+          <a:bodyPr wrap="none">
+            <a:spAutoFit/>
+          </a:bodyPr>
+          <a:lstStyle/>
+          <a:p>
+            <a:pPr>
+              <a:defRPr sz="2800" b="1">
+                <a:solidFill>
+                  <a:srgbClr val="0F172A"/>
+                </a:solidFill>
+                <a:latin typeface="Segoe UI"/>
+              </a:defRPr>
+            </a:pPr>
+            <a:r>
+              <a:t>CAREGIVER PORTAL &amp; GEOFENCE SAFETY GUARD</a:t>
+            </a:r>
+          </a:p>
+        </p:txBody>
+      </p:sp>
+      <p:sp>
+        <p:nvSpPr>
+          <p:cNvPr id="3" name="Oval 2"/>
+          <p:cNvSpPr/>
+          <p:nvPr/>
+        </p:nvSpPr>
+        <p:spPr>
+          <a:xfrm>
+            <a:off x="330098" y="252374"/>
+            <a:ext cx="1251813" cy="807415"/>
+          </a:xfrm>
+          <a:prstGeom prst="ellipse">
+            <a:avLst/>
+          </a:prstGeom>
+          <a:solidFill>
+            <a:srgbClr val="10B981"/>
+          </a:solidFill>
+          <a:ln>
+            <a:solidFill>
+              <a:srgbClr val="059669"/>
+            </a:solidFill>
+          </a:ln>
+        </p:spPr>
+        <p:style>
+          <a:lnRef idx="1">
+            <a:schemeClr val="accent1"/>
+          </a:lnRef>
+          <a:fillRef idx="3">
+            <a:schemeClr val="accent1"/>
+          </a:fillRef>
+          <a:effectRef idx="2">
+            <a:schemeClr val="accent1"/>
+          </a:effectRef>
+          <a:fontRef idx="minor">
+            <a:schemeClr val="lt1"/>
+          </a:fontRef>
+        </p:style>
+        <p:txBody>
+          <a:bodyPr rtlCol="0" anchor="ctr"/>
+          <a:lstStyle/>
+          <a:p>
+            <a:pPr algn="ctr">
+              <a:defRPr sz="900" b="1">
+                <a:solidFill>
+                  <a:srgbClr val="FFFFFF"/>
+                </a:solidFill>
+              </a:defRPr>
+            </a:pPr>
+            <a:r>
+              <a:t>TEAM NAME</a:t>
+            </a:r>
+          </a:p>
+        </p:txBody>
+      </p:sp>
+      <p:sp>
+        <p:nvSpPr>
+          <p:cNvPr id="4" name="TextBox 3"/>
+          <p:cNvSpPr txBox="1"/>
+          <p:nvPr/>
+        </p:nvSpPr>
+        <p:spPr>
+          <a:xfrm>
+            <a:off x="4647895" y="6355994"/>
+            <a:ext cx="3204057" cy="364845"/>
+          </a:xfrm>
+          <a:prstGeom prst="rect">
+            <a:avLst/>
+          </a:prstGeom>
+          <a:noFill/>
+        </p:spPr>
+        <p:txBody>
+          <a:bodyPr wrap="none">
+            <a:spAutoFit/>
+          </a:bodyPr>
+          <a:lstStyle/>
+          <a:p>
+            <a:pPr>
+              <a:defRPr sz="1000">
+                <a:solidFill>
+                  <a:srgbClr val="94A3B8"/>
+                </a:solidFill>
+              </a:defRPr>
+            </a:pPr>
+            <a:r>
+              <a:t>@SIH Idea submission- Template</a:t>
+            </a:r>
+          </a:p>
+        </p:txBody>
+      </p:sp>
+      <p:sp>
+        <p:nvSpPr>
+          <p:cNvPr id="5" name="TextBox 4"/>
+          <p:cNvSpPr txBox="1"/>
+          <p:nvPr/>
+        </p:nvSpPr>
+        <p:spPr>
+          <a:xfrm>
+            <a:off x="8738006" y="6355994"/>
+            <a:ext cx="2844698" cy="364845"/>
+          </a:xfrm>
+          <a:prstGeom prst="rect">
+            <a:avLst/>
+          </a:prstGeom>
+          <a:noFill/>
+        </p:spPr>
+        <p:txBody>
+          <a:bodyPr wrap="none">
+            <a:spAutoFit/>
+          </a:bodyPr>
+          <a:lstStyle/>
+          <a:p>
+            <a:pPr>
+              <a:defRPr sz="1000" b="1">
+                <a:solidFill>
+                  <a:srgbClr val="94A3B8"/>
+                </a:solidFill>
+              </a:defRPr>
+            </a:pPr>
+            <a:r>
+              <a:t>9</a:t>
+            </a:r>
+          </a:p>
+        </p:txBody>
+      </p:sp>
+      <p:pic>
+        <p:nvPicPr>
+          <p:cNvPr id="6" name="Picture 5" descr="screenshot_caregiver.png"/>
+          <p:cNvPicPr>
+            <a:picLocks noChangeAspect="1"/>
+          </p:cNvPicPr>
+          <p:nvPr/>
+        </p:nvPicPr>
+        <p:blipFill>
+          <a:blip r:embed="rId2"/>
+          <a:stretch>
+            <a:fillRect/>
+          </a:stretch>
+        </p:blipFill>
+        <p:spPr>
+          <a:xfrm>
+            <a:off x="731520" y="1188720"/>
+            <a:ext cx="7315200" cy="4937760"/>
+          </a:xfrm>
+          <a:prstGeom prst="rect">
+            <a:avLst/>
+          </a:prstGeom>
+        </p:spPr>
+      </p:pic>
+      <p:sp>
+        <p:nvSpPr>
+          <p:cNvPr id="7" name="Rounded Rectangle 6"/>
+          <p:cNvSpPr/>
+          <p:nvPr/>
+        </p:nvSpPr>
+        <p:spPr>
+          <a:xfrm>
+            <a:off x="8321040" y="1188720"/>
+            <a:ext cx="3139135" cy="4937760"/>
+          </a:xfrm>
+          <a:prstGeom prst="roundRect">
+            <a:avLst/>
+          </a:prstGeom>
+          <a:solidFill>
+            <a:srgbClr val="F8FAFC"/>
+          </a:solidFill>
+          <a:ln>
+            <a:solidFill>
+              <a:srgbClr val="CBD5E1"/>
+            </a:solidFill>
+          </a:ln>
+        </p:spPr>
+        <p:style>
+          <a:lnRef idx="1">
+            <a:schemeClr val="accent1"/>
+          </a:lnRef>
+          <a:fillRef idx="3">
+            <a:schemeClr val="accent1"/>
+          </a:fillRef>
+          <a:effectRef idx="2">
+            <a:schemeClr val="accent1"/>
+          </a:effectRef>
+          <a:fontRef idx="minor">
+            <a:schemeClr val="lt1"/>
+          </a:fontRef>
+        </p:style>
+        <p:txBody>
+          <a:bodyPr rtlCol="0" anchor="ctr" wrap="square" lIns="182880" tIns="228600"/>
+          <a:lstStyle/>
+          <a:p>
+            <a:pPr algn="ctr">
+              <a:defRPr b="1" sz="1500">
+                <a:solidFill>
+                  <a:srgbClr val="057A55"/>
+                </a:solidFill>
+              </a:defRPr>
+            </a:pPr>
+            <a:r>
+              <a:t>Clinical Intelligence Highlights</a:t>
+            </a:r>
+          </a:p>
+          <a:p>
+            <a:pPr>
+              <a:spcBef>
+                <a:spcPts val="800"/>
+              </a:spcBef>
+              <a:defRPr sz="1100">
+                <a:solidFill>
+                  <a:srgbClr val="334155"/>
+                </a:solidFill>
+              </a:defRPr>
+            </a:pPr>
+            <a:r>
+              <a:t>• MoCA Domain Radar: Quantifies Memory (78%), Attention (84%), Visuospatial (80%), and Routine (86%).</a:t>
+            </a:r>
+          </a:p>
+          <a:p>
+            <a:pPr>
+              <a:spcBef>
+                <a:spcPts val="800"/>
+              </a:spcBef>
+              <a:defRPr sz="1100">
+                <a:solidFill>
+                  <a:srgbClr val="334155"/>
+                </a:solidFill>
+              </a:defRPr>
+            </a:pPr>
+            <a:r>
+              <a:t>• Weekly Latency Curve: Tracks reaction speed from Monday to Sunday; alerts on sudden cognitive drops (&gt;15%).</a:t>
+            </a:r>
+          </a:p>
+          <a:p>
+            <a:pPr>
+              <a:spcBef>
+                <a:spcPts val="800"/>
+              </a:spcBef>
+              <a:defRPr sz="1100">
+                <a:solidFill>
+                  <a:srgbClr val="334155"/>
+                </a:solidFill>
+              </a:defRPr>
+            </a:pPr>
+            <a:r>
+              <a:t>• GPS Safe-Zone Guard: Simulated 300m geofence around Guwahati residence; dispatches instant SMS alerts on breach.</a:t>
+            </a:r>
+          </a:p>
+          <a:p>
+            <a:pPr>
+              <a:spcBef>
+                <a:spcPts val="800"/>
+              </a:spcBef>
+              <a:defRPr sz="1100">
+                <a:solidFill>
+                  <a:srgbClr val="334155"/>
+                </a:solidFill>
+              </a:defRPr>
+            </a:pPr>
+            <a:r>
+              <a:t>• Doctor PDF Export: Generates comprehensive progress reports for Guwahati Medical College consultations.</a:t>
+            </a:r>
+          </a:p>
+        </p:txBody>
+      </p:sp>
+    </p:spTree>
+  </p:cSld>
+  <p:clrMapOvr>
+    <a:masterClrMapping/>
+  </p:clrMapOvr>
+</p:sld>
+</file>
+
 <file path=ppt/theme/theme1.xml><?xml version="1.0" encoding="utf-8"?>
 <a:theme xmlns:a="http://schemas.openxmlformats.org/drawingml/2006/main" name="Office Theme">
   <a:themeElements>

</xml_diff>